<commit_message>
Merge model-replaceability and data-source compliance points into architecture slide
</commit_message>
<xml_diff>
--- a/ppt/orbit_engine_value_proposal_v2.pptx
+++ b/ppt/orbit_engine_value_proposal_v2.pptx
@@ -25695,7 +25695,7 @@
                 </a:solidFill>
                 <a:latin typeface="Noto Sans CJK SC"/>
               </a:rPr>
-              <a:t>LLM: OpenRouter 可切换(mock 默认)</a:t>
+              <a:t>LLM: OpenRouter 可切换(mock 默认) · 可替换开源(仅 Prompt 适配)</a:t>
             </a:r>
           </a:p>
           <a:p>
@@ -25991,6 +25991,18 @@
                 <a:latin typeface="Noto Sans CJK SC"/>
               </a:rPr>
               <a:t>用户数据可一键删除</a:t>
+            </a:r>
+          </a:p>
+          <a:p>
+            <a:pPr/>
+            <a:r>
+              <a:rPr sz="950" b="0">
+                <a:solidFill>
+                  <a:srgbClr val="1C202C"/>
+                </a:solidFill>
+                <a:latin typeface="Noto Sans CJK SC"/>
+              </a:rPr>
+              <a:t>仅公开源 + 用户自主提供 · UI 标注来源</a:t>
             </a:r>
           </a:p>
         </p:txBody>

</xml_diff>